<commit_message>
objectius + cami tornada. presentacio ia
</commit_message>
<xml_diff>
--- a/P000 - Història conversacional/docs/presentacio/presentacio.pptx
+++ b/P000 - Història conversacional/docs/presentacio/presentacio.pptx
@@ -8,11 +8,11 @@
     <p:sldId id="256" r:id="rId7"/>
     <p:sldId id="257" r:id="rId9"/>
     <p:sldId id="258" r:id="rId10"/>
+    <p:sldId id="263" r:id="rId15"/>
     <p:sldId id="259" r:id="rId11"/>
     <p:sldId id="260" r:id="rId12"/>
     <p:sldId id="261" r:id="rId13"/>
     <p:sldId id="262" r:id="rId14"/>
-    <p:sldId id="263" r:id="rId15"/>
     <p:sldId id="264" r:id="rId16"/>
     <p:sldId id="265" r:id="rId17"/>
   </p:sldIdLst>
@@ -724,7 +724,7 @@
           <a:lstStyle/>
           <a:p>
             <a:r>
-              <a:t>0:45 - 1:45  L'ENUNCIAT</a:t>
+              <a:t>0:45 - 1:30  L'ENUNCIAT</a:t>
             </a:r>
           </a:p>
           <a:p/>
@@ -812,7 +812,7 @@
           <a:lstStyle/>
           <a:p>
             <a:r>
-              <a:t>1:45 - 2:45  EL MAPA</a:t>
+              <a:t>1:30 - 2:30  EL MAPA</a:t>
             </a:r>
           </a:p>
           <a:p/>
@@ -906,7 +906,7 @@
           <a:lstStyle/>
           <a:p>
             <a:r>
-              <a:t>2:45 - 3:05  ARQUITECTURA, VISTA GENERAL</a:t>
+              <a:t>4:45 - 5:05  ARQUITECTURA, VISTA GENERAL</a:t>
             </a:r>
           </a:p>
           <a:p/>
@@ -988,7 +988,7 @@
           <a:lstStyle/>
           <a:p>
             <a:r>
-              <a:t>3:05 - 3:55  DECISIO 1</a:t>
+              <a:t>5:05 - 5:55  DECISIO 1</a:t>
             </a:r>
           </a:p>
           <a:p/>
@@ -1076,7 +1076,7 @@
           <a:lstStyle/>
           <a:p>
             <a:r>
-              <a:t>3:55 - 4:35  DECISIO 2</a:t>
+              <a:t>5:55 - 6:35  DECISIO 2</a:t>
             </a:r>
           </a:p>
           <a:p/>
@@ -1100,7 +1100,7 @@
           <a:p/>
           <a:p>
             <a:r>
-              <a:t>AQUESTA ES LA DIAPOSITIVA QUE ES TALLA si a les 5:15 no has arribat a la demostracio.</a:t>
+              <a:t>SI VAS TARD, AQUESTA ES LA QUE ES POT RESUMIR EN DUES FRASES.</a:t>
             </a:r>
           </a:p>
         </p:txBody>
@@ -1170,7 +1170,7 @@
           <a:lstStyle/>
           <a:p>
             <a:r>
-              <a:t>4:35 - 5:15  DECISIO 3</a:t>
+              <a:t>6:35 - 7:30  DECISIO 3</a:t>
             </a:r>
           </a:p>
           <a:p/>
@@ -1194,7 +1194,7 @@
           <a:p/>
           <a:p>
             <a:r>
-              <a:t>A LES 5:15 HAS DE PASSAR A LA DEMOSTRACIO.</a:t>
+              <a:t>A LES 7:30 HAS DE PASSAR AL TESTING. Aquesta diapositiva no es toca.</a:t>
             </a:r>
           </a:p>
         </p:txBody>
@@ -1264,13 +1264,13 @@
           <a:lstStyle/>
           <a:p>
             <a:r>
-              <a:t>5:15 - 7:30  DEMOSTRACIO</a:t>
+              <a:t>2:30 - 4:45  DEMOSTRACIO</a:t>
             </a:r>
           </a:p>
           <a:p/>
           <a:p>
             <a:r>
-              <a:t>SEGON I ULTIM CANVI DE FINESTRA.</a:t>
+              <a:t>PRIMER CANVI DE FINESTRA: entres al joc. En sortir, el segon i ultim.</a:t>
             </a:r>
           </a:p>
           <a:p/>
@@ -7172,7 +7172,7 @@
                 </a:solidFill>
                 <a:latin typeface="Segoe UI"/>
               </a:rPr>
-              <a:t>1:45</a:t>
+              <a:t>1:30</a:t>
             </a:r>
           </a:p>
         </p:txBody>
@@ -8797,7 +8797,7 @@
                 </a:solidFill>
                 <a:latin typeface="Segoe UI"/>
               </a:rPr>
-              <a:t>2:45</a:t>
+              <a:t>4:45</a:t>
             </a:r>
           </a:p>
         </p:txBody>
@@ -10087,7 +10087,7 @@
                 </a:solidFill>
                 <a:latin typeface="Segoe UI"/>
               </a:rPr>
-              <a:t>3:05</a:t>
+              <a:t>5:05</a:t>
             </a:r>
           </a:p>
         </p:txBody>
@@ -11429,7 +11429,7 @@
                 </a:solidFill>
                 <a:latin typeface="Segoe UI"/>
               </a:rPr>
-              <a:t>3:55</a:t>
+              <a:t>5:55</a:t>
             </a:r>
           </a:p>
         </p:txBody>
@@ -12455,7 +12455,7 @@
                 </a:solidFill>
                 <a:latin typeface="Segoe UI"/>
               </a:rPr>
-              <a:t>4:35</a:t>
+              <a:t>6:35</a:t>
             </a:r>
           </a:p>
         </p:txBody>
@@ -13570,7 +13570,7 @@
                 </a:solidFill>
                 <a:latin typeface="Segoe UI"/>
               </a:rPr>
-              <a:t>5:15</a:t>
+              <a:t>2:30</a:t>
             </a:r>
           </a:p>
         </p:txBody>

</xml_diff>